<commit_message>
feat: add seismic grid API and integrate earthquake shaking layer into UI
</commit_message>
<xml_diff>
--- a/Submission Template - AI Builder Cup.pptx
+++ b/Submission Template - AI Builder Cup.pptx
@@ -967,7 +967,7 @@
         </p:nvSpPr>
         <p:spPr>
           <a:xfrm>
-            <a:off x="381300" y="685800"/>
+            <a:off x="381000" y="685800"/>
             <a:ext cx="6096000" cy="3429000"/>
           </a:xfrm>
           <a:custGeom>
@@ -1071,7 +1071,7 @@
         </p:nvSpPr>
         <p:spPr>
           <a:xfrm>
-            <a:off x="381300" y="685800"/>
+            <a:off x="381000" y="685800"/>
             <a:ext cx="6096000" cy="3429000"/>
           </a:xfrm>
           <a:custGeom>
@@ -1383,7 +1383,7 @@
         </p:nvSpPr>
         <p:spPr>
           <a:xfrm>
-            <a:off x="381300" y="685800"/>
+            <a:off x="381000" y="685800"/>
             <a:ext cx="6096000" cy="3429000"/>
           </a:xfrm>
           <a:custGeom>
@@ -1591,7 +1591,7 @@
         </p:nvSpPr>
         <p:spPr>
           <a:xfrm>
-            <a:off x="381300" y="685800"/>
+            <a:off x="381000" y="685800"/>
             <a:ext cx="6096000" cy="3429000"/>
           </a:xfrm>
           <a:custGeom>
@@ -1799,7 +1799,7 @@
         </p:nvSpPr>
         <p:spPr>
           <a:xfrm>
-            <a:off x="381300" y="685800"/>
+            <a:off x="381000" y="685800"/>
             <a:ext cx="6096000" cy="3429000"/>
           </a:xfrm>
           <a:custGeom>
@@ -1903,7 +1903,7 @@
         </p:nvSpPr>
         <p:spPr>
           <a:xfrm>
-            <a:off x="381300" y="685800"/>
+            <a:off x="381000" y="685800"/>
             <a:ext cx="6096000" cy="3429000"/>
           </a:xfrm>
           <a:custGeom>
@@ -7836,7 +7836,7 @@
               </a:spcAft>
             </a:pPr>
             <a:r>
-              <a:rPr sz="1300" b="0">
+              <a:rPr sz="1300" b="0" dirty="0">
                 <a:solidFill>
                   <a:srgbClr val="262A2E"/>
                 </a:solidFill>
@@ -7855,7 +7855,7 @@
               </a:spcAft>
             </a:pPr>
             <a:r>
-              <a:rPr sz="1300" b="0">
+              <a:rPr sz="1300" b="0" dirty="0">
                 <a:solidFill>
                   <a:srgbClr val="262A2E"/>
                 </a:solidFill>
@@ -7874,13 +7874,31 @@
               </a:spcAft>
             </a:pPr>
             <a:r>
-              <a:rPr sz="1300" b="0">
+              <a:rPr sz="1300" b="0" dirty="0">
                 <a:solidFill>
                   <a:srgbClr val="262A2E"/>
                 </a:solidFill>
                 <a:latin typeface="Google Sans Flex Medium"/>
               </a:rPr>
-              <a:t>•  Extend the validated tier beyond Kochi, wherever an official depth map is published.</a:t>
+              <a:t>•  Extend the validated tier beyond Kochi</a:t>
+            </a:r>
+            <a:r>
+              <a:rPr lang="en-US" sz="1300" b="0" dirty="0">
+                <a:solidFill>
+                  <a:srgbClr val="262A2E"/>
+                </a:solidFill>
+                <a:latin typeface="Google Sans Flex Medium"/>
+              </a:rPr>
+              <a:t> and Singapore</a:t>
+            </a:r>
+            <a:r>
+              <a:rPr sz="1300" b="0" dirty="0">
+                <a:solidFill>
+                  <a:srgbClr val="262A2E"/>
+                </a:solidFill>
+                <a:latin typeface="Google Sans Flex Medium"/>
+              </a:rPr>
+              <a:t>, wherever an official depth map is published.</a:t>
             </a:r>
           </a:p>
           <a:p>
@@ -7893,13 +7911,31 @@
               </a:spcAft>
             </a:pPr>
             <a:r>
-              <a:rPr sz="1300" b="0">
+              <a:rPr sz="1300" b="0" dirty="0">
                 <a:solidFill>
                   <a:srgbClr val="262A2E"/>
                 </a:solidFill>
                 <a:latin typeface="Google Sans Flex Medium"/>
               </a:rPr>
-              <a:t>•  Ingest live rain-gauge feeds where they are open (NEA is wired for Singapore; generalise it).</a:t>
+              <a:t>•  Ingest live rain-gauge feeds where they are open (NEA is wired for Singapore; </a:t>
+            </a:r>
+            <a:r>
+              <a:rPr sz="1300" b="0" dirty="0" err="1">
+                <a:solidFill>
+                  <a:srgbClr val="262A2E"/>
+                </a:solidFill>
+                <a:latin typeface="Google Sans Flex Medium"/>
+              </a:rPr>
+              <a:t>generalise</a:t>
+            </a:r>
+            <a:r>
+              <a:rPr sz="1300" b="0" dirty="0">
+                <a:solidFill>
+                  <a:srgbClr val="262A2E"/>
+                </a:solidFill>
+                <a:latin typeface="Google Sans Flex Medium"/>
+              </a:rPr>
+              <a:t> it).</a:t>
             </a:r>
           </a:p>
           <a:p>
@@ -7912,7 +7948,7 @@
               </a:spcAft>
             </a:pPr>
             <a:r>
-              <a:rPr sz="1300" b="0">
+              <a:rPr sz="1300" b="0" dirty="0">
                 <a:solidFill>
                   <a:srgbClr val="262A2E"/>
                 </a:solidFill>
@@ -7931,7 +7967,7 @@
               </a:spcAft>
             </a:pPr>
             <a:r>
-              <a:rPr sz="1300" b="0">
+              <a:rPr sz="1300" b="0" dirty="0">
                 <a:solidFill>
                   <a:srgbClr val="262A2E"/>
                 </a:solidFill>
@@ -8070,7 +8106,7 @@
         </p:nvSpPr>
         <p:spPr>
           <a:xfrm>
-            <a:off x="265350" y="663825"/>
+            <a:off x="201000" y="1672647"/>
             <a:ext cx="8943000" cy="1333800"/>
           </a:xfrm>
           <a:prstGeom prst="rect">
@@ -8096,15 +8132,6 @@
               </a:spcAft>
               <a:buNone/>
             </a:pPr>
-            <a:r>
-              <a:rPr lang="en-GB" sz="1600" dirty="0">
-                <a:latin typeface="Google Sans Flex Medium"/>
-                <a:ea typeface="Google Sans Flex Medium"/>
-                <a:cs typeface="Google Sans Flex Medium"/>
-                <a:sym typeface="Google Sans Flex Medium"/>
-              </a:rPr>
-              <a:t>Provide links to your:</a:t>
-            </a:r>
             <a:endParaRPr sz="1600" dirty="0">
               <a:latin typeface="Google Sans Flex Medium"/>
               <a:ea typeface="Google Sans Flex Medium"/>
@@ -8113,30 +8140,7 @@
             </a:endParaRPr>
           </a:p>
           <a:p>
-            <a:pPr marL="0" lvl="0" indent="0" algn="l" rtl="0">
-              <a:spcBef>
-                <a:spcPts val="0"/>
-              </a:spcBef>
-              <a:spcAft>
-                <a:spcPts val="0"/>
-              </a:spcAft>
-              <a:buNone/>
-            </a:pPr>
-            <a:endParaRPr sz="1600" dirty="0">
-              <a:latin typeface="Google Sans Flex Medium"/>
-              <a:ea typeface="Google Sans Flex Medium"/>
-              <a:cs typeface="Google Sans Flex Medium"/>
-              <a:sym typeface="Google Sans Flex Medium"/>
-            </a:endParaRPr>
-          </a:p>
-          <a:p>
-            <a:pPr marL="457200" lvl="0" indent="-317500" algn="l" rtl="0">
-              <a:spcBef>
-                <a:spcPts val="0"/>
-              </a:spcBef>
-              <a:spcAft>
-                <a:spcPts val="0"/>
-              </a:spcAft>
+            <a:pPr marL="457200" lvl="0" indent="-317500">
               <a:buSzPts val="1400"/>
               <a:buFont typeface="Google Sans Flex Medium"/>
               <a:buChar char="●"/>
@@ -8157,13 +8161,23 @@
                 </a:solidFill>
                 <a:latin typeface="Google Sans Flex Medium"/>
               </a:rPr>
-              <a:t> : [GITHUB REPO URL, make it public]</a:t>
-            </a:r>
-            <a:endParaRPr dirty="0">
+              <a:t> : </a:t>
+            </a:r>
+            <a:r>
+              <a:rPr lang="en-US" dirty="0">
+                <a:solidFill>
+                  <a:srgbClr val="262A2E"/>
+                </a:solidFill>
+                <a:latin typeface="Google Sans Flex Medium"/>
+                <a:hlinkClick r:id="rId5"/>
+              </a:rPr>
+              <a:t>https://github.com/anduriroshan/before-it-hits</a:t>
+            </a:r>
+            <a:endParaRPr lang="en-US" dirty="0">
+              <a:solidFill>
+                <a:srgbClr val="262A2E"/>
+              </a:solidFill>
               <a:latin typeface="Google Sans Flex Medium"/>
-              <a:ea typeface="Google Sans Flex Medium"/>
-              <a:cs typeface="Google Sans Flex Medium"/>
-              <a:sym typeface="Google Sans Flex Medium"/>
             </a:endParaRPr>
           </a:p>
           <a:p>
@@ -8185,7 +8199,7 @@
                 <a:cs typeface="Google Sans Flex Medium"/>
                 <a:sym typeface="Google Sans Flex Medium"/>
               </a:rPr>
-              <a:t>Demo Video Link (3 Minutes)</a:t>
+              <a:t>Demo Video Link </a:t>
             </a:r>
             <a:r>
               <a:rPr dirty="0">
@@ -8194,23 +8208,27 @@
                 </a:solidFill>
                 <a:latin typeface="Google Sans Flex Medium"/>
               </a:rPr>
-              <a:t> : [DEMO VIDEO LINK, 3 min]</a:t>
-            </a:r>
-            <a:endParaRPr dirty="0">
+              <a:t>: </a:t>
+            </a:r>
+            <a:r>
+              <a:rPr lang="en-US" dirty="0">
+                <a:solidFill>
+                  <a:srgbClr val="262A2E"/>
+                </a:solidFill>
+                <a:latin typeface="Google Sans Flex Medium"/>
+                <a:hlinkClick r:id="rId6"/>
+              </a:rPr>
+              <a:t>https://youtu.be/dL2FW3YUnB8</a:t>
+            </a:r>
+            <a:endParaRPr lang="en-US" dirty="0">
+              <a:solidFill>
+                <a:srgbClr val="262A2E"/>
+              </a:solidFill>
               <a:latin typeface="Google Sans Flex Medium"/>
-              <a:ea typeface="Google Sans Flex Medium"/>
-              <a:cs typeface="Google Sans Flex Medium"/>
-              <a:sym typeface="Google Sans Flex Medium"/>
             </a:endParaRPr>
           </a:p>
           <a:p>
-            <a:pPr marL="457200" lvl="0" indent="-317500" algn="l" rtl="0">
-              <a:spcBef>
-                <a:spcPts val="0"/>
-              </a:spcBef>
-              <a:spcAft>
-                <a:spcPts val="0"/>
-              </a:spcAft>
+            <a:pPr marL="457200" lvl="0" indent="-317500">
               <a:buSzPts val="1400"/>
               <a:buFont typeface="Google Sans Flex Medium"/>
               <a:buChar char="●"/>
@@ -8231,7 +8249,17 @@
                 </a:solidFill>
                 <a:latin typeface="Google Sans Flex Medium"/>
               </a:rPr>
-              <a:t> : https://before-it-hits-z5r5gsxkza-el.a.run.app</a:t>
+              <a:t> : </a:t>
+            </a:r>
+            <a:r>
+              <a:rPr dirty="0">
+                <a:solidFill>
+                  <a:srgbClr val="262A2E"/>
+                </a:solidFill>
+                <a:latin typeface="Google Sans Flex Medium"/>
+                <a:hlinkClick r:id="rId7"/>
+              </a:rPr>
+              <a:t>https://before-it-hits-z5r5gsxkza-el.a.run.app</a:t>
             </a:r>
             <a:endParaRPr dirty="0">
               <a:latin typeface="Google Sans Flex Medium"/>
@@ -8738,7 +8766,7 @@
               <a:buNone/>
             </a:pPr>
             <a:r>
-              <a:rPr lang="en-GB" sz="1600">
+              <a:rPr lang="en-GB" sz="1600" dirty="0">
                 <a:latin typeface="Google Sans Flex SemiBold"/>
                 <a:ea typeface="Google Sans Flex SemiBold"/>
                 <a:cs typeface="Google Sans Flex SemiBold"/>
@@ -8747,14 +8775,14 @@
               <a:t>Opportunities</a:t>
             </a:r>
             <a:br>
-              <a:rPr lang="en-GB" sz="1600">
+              <a:rPr lang="en-GB" sz="1600" dirty="0">
                 <a:latin typeface="Google Sans Flex SemiBold"/>
                 <a:ea typeface="Google Sans Flex SemiBold"/>
                 <a:cs typeface="Google Sans Flex SemiBold"/>
                 <a:sym typeface="Google Sans Flex SemiBold"/>
               </a:rPr>
             </a:br>
-            <a:endParaRPr sz="1600">
+            <a:endParaRPr sz="1600" dirty="0">
               <a:latin typeface="Google Sans Flex SemiBold"/>
               <a:ea typeface="Google Sans Flex SemiBold"/>
               <a:cs typeface="Google Sans Flex SemiBold"/>
@@ -8762,90 +8790,6 @@
             </a:endParaRPr>
           </a:p>
           <a:p>
-            <a:pPr marL="457200" lvl="0" indent="-311150" algn="l" rtl="0">
-              <a:spcBef>
-                <a:spcPts val="0"/>
-              </a:spcBef>
-              <a:spcAft>
-                <a:spcPts val="0"/>
-              </a:spcAft>
-              <a:buSzPts val="1300"/>
-              <a:buFont typeface="Google Sans Flex"/>
-              <a:buChar char="●"/>
-            </a:pPr>
-            <a:r>
-              <a:rPr lang="en-GB" sz="1300">
-                <a:latin typeface="Google Sans Flex"/>
-                <a:ea typeface="Google Sans Flex"/>
-                <a:cs typeface="Google Sans Flex"/>
-                <a:sym typeface="Google Sans Flex"/>
-              </a:rPr>
-              <a:t>How different is it from any of the other existing ideas?</a:t>
-            </a:r>
-            <a:endParaRPr sz="1300">
-              <a:latin typeface="Google Sans Flex"/>
-              <a:ea typeface="Google Sans Flex"/>
-              <a:cs typeface="Google Sans Flex"/>
-              <a:sym typeface="Google Sans Flex"/>
-            </a:endParaRPr>
-          </a:p>
-          <a:p>
-            <a:pPr marL="457200" lvl="0" indent="-311150" algn="l" rtl="0">
-              <a:spcBef>
-                <a:spcPts val="0"/>
-              </a:spcBef>
-              <a:spcAft>
-                <a:spcPts val="0"/>
-              </a:spcAft>
-              <a:buSzPts val="1300"/>
-              <a:buFont typeface="Google Sans Flex"/>
-              <a:buChar char="●"/>
-            </a:pPr>
-            <a:r>
-              <a:rPr lang="en-GB" sz="1300">
-                <a:latin typeface="Google Sans Flex"/>
-                <a:ea typeface="Google Sans Flex"/>
-                <a:cs typeface="Google Sans Flex"/>
-                <a:sym typeface="Google Sans Flex"/>
-              </a:rPr>
-              <a:t>How will it be able to solve the problem?</a:t>
-            </a:r>
-            <a:endParaRPr sz="1300">
-              <a:latin typeface="Google Sans Flex"/>
-              <a:ea typeface="Google Sans Flex"/>
-              <a:cs typeface="Google Sans Flex"/>
-              <a:sym typeface="Google Sans Flex"/>
-            </a:endParaRPr>
-          </a:p>
-          <a:p>
-            <a:pPr marL="457200" lvl="0" indent="-311150" algn="l" rtl="0">
-              <a:spcBef>
-                <a:spcPts val="0"/>
-              </a:spcBef>
-              <a:spcAft>
-                <a:spcPts val="0"/>
-              </a:spcAft>
-              <a:buSzPts val="1300"/>
-              <a:buFont typeface="Google Sans Flex"/>
-              <a:buChar char="●"/>
-            </a:pPr>
-            <a:r>
-              <a:rPr lang="en-GB" sz="1300">
-                <a:latin typeface="Google Sans Flex"/>
-                <a:ea typeface="Google Sans Flex"/>
-                <a:cs typeface="Google Sans Flex"/>
-                <a:sym typeface="Google Sans Flex"/>
-              </a:rPr>
-              <a:t>USP of the proposed solution</a:t>
-            </a:r>
-            <a:endParaRPr sz="1300">
-              <a:latin typeface="Google Sans Flex"/>
-              <a:ea typeface="Google Sans Flex"/>
-              <a:cs typeface="Google Sans Flex"/>
-              <a:sym typeface="Google Sans Flex"/>
-            </a:endParaRPr>
-          </a:p>
-          <a:p>
             <a:pPr marL="0" lvl="0" indent="0" algn="l" rtl="0">
               <a:spcBef>
                 <a:spcPts val="0"/>
@@ -8855,7 +8799,7 @@
               </a:spcAft>
               <a:buNone/>
             </a:pPr>
-            <a:endParaRPr sz="1600">
+            <a:endParaRPr sz="1600" dirty="0">
               <a:latin typeface="Google Sans Flex Medium"/>
               <a:ea typeface="Google Sans Flex Medium"/>
               <a:cs typeface="Google Sans Flex Medium"/>
@@ -8872,7 +8816,7 @@
               </a:spcAft>
               <a:buNone/>
             </a:pPr>
-            <a:endParaRPr sz="1600">
+            <a:endParaRPr sz="1600" dirty="0">
               <a:latin typeface="Google Sans Flex Medium"/>
               <a:ea typeface="Google Sans Flex Medium"/>
               <a:cs typeface="Google Sans Flex Medium"/>
@@ -8889,7 +8833,7 @@
         </p:nvSpPr>
         <p:spPr>
           <a:xfrm>
-            <a:off x="365760" y="2121408"/>
+            <a:off x="351210" y="1346925"/>
             <a:ext cx="8412480" cy="2788920"/>
           </a:xfrm>
           <a:prstGeom prst="rect">
@@ -8912,7 +8856,7 @@
               </a:spcAft>
             </a:pPr>
             <a:r>
-              <a:rPr sz="1150" b="1">
+              <a:rPr sz="1150" b="1" dirty="0">
                 <a:solidFill>
                   <a:srgbClr val="056F9E"/>
                 </a:solidFill>
@@ -8931,7 +8875,7 @@
               </a:spcAft>
             </a:pPr>
             <a:r>
-              <a:rPr sz="1050" b="0">
+              <a:rPr sz="1050" b="0" dirty="0">
                 <a:solidFill>
                   <a:srgbClr val="262A2E"/>
                 </a:solidFill>
@@ -8950,7 +8894,7 @@
               </a:spcAft>
             </a:pPr>
             <a:r>
-              <a:rPr sz="1050" b="0">
+              <a:rPr sz="1050" b="0" dirty="0">
                 <a:solidFill>
                   <a:srgbClr val="262A2E"/>
                 </a:solidFill>
@@ -8969,7 +8913,7 @@
               </a:spcAft>
             </a:pPr>
             <a:r>
-              <a:rPr sz="1150" b="1">
+              <a:rPr sz="1150" b="1" dirty="0">
                 <a:solidFill>
                   <a:srgbClr val="056F9E"/>
                 </a:solidFill>
@@ -8988,7 +8932,7 @@
               </a:spcAft>
             </a:pPr>
             <a:r>
-              <a:rPr sz="1050" b="0">
+              <a:rPr sz="1050" b="0" dirty="0">
                 <a:solidFill>
                   <a:srgbClr val="262A2E"/>
                 </a:solidFill>
@@ -9007,7 +8951,7 @@
               </a:spcAft>
             </a:pPr>
             <a:r>
-              <a:rPr sz="1050" b="0">
+              <a:rPr sz="1050" b="0" dirty="0">
                 <a:solidFill>
                   <a:srgbClr val="262A2E"/>
                 </a:solidFill>
@@ -9026,7 +8970,7 @@
               </a:spcAft>
             </a:pPr>
             <a:r>
-              <a:rPr sz="1050" b="0">
+              <a:rPr sz="1050" b="0" dirty="0">
                 <a:solidFill>
                   <a:srgbClr val="262A2E"/>
                 </a:solidFill>
@@ -9045,7 +8989,7 @@
               </a:spcAft>
             </a:pPr>
             <a:r>
-              <a:rPr sz="1150" b="1">
+              <a:rPr sz="1150" b="1" dirty="0">
                 <a:solidFill>
                   <a:srgbClr val="056F9E"/>
                 </a:solidFill>
@@ -9064,7 +9008,7 @@
               </a:spcAft>
             </a:pPr>
             <a:r>
-              <a:rPr sz="1050" b="0">
+              <a:rPr sz="1050" b="0" dirty="0">
                 <a:solidFill>
                   <a:srgbClr val="262A2E"/>
                 </a:solidFill>
@@ -9083,7 +9027,7 @@
               </a:spcAft>
             </a:pPr>
             <a:r>
-              <a:rPr sz="1050" b="0">
+              <a:rPr sz="1050" b="0" dirty="0">
                 <a:solidFill>
                   <a:srgbClr val="262A2E"/>
                 </a:solidFill>
@@ -9102,7 +9046,7 @@
               </a:spcAft>
             </a:pPr>
             <a:r>
-              <a:rPr sz="1050" b="0">
+              <a:rPr sz="1050" b="0" dirty="0">
                 <a:solidFill>
                   <a:srgbClr val="262A2E"/>
                 </a:solidFill>
@@ -9316,7 +9260,7 @@
               </a:spcAft>
             </a:pPr>
             <a:r>
-              <a:rPr sz="1150" b="0">
+              <a:rPr sz="1150" b="0" dirty="0">
                 <a:solidFill>
                   <a:srgbClr val="262A2E"/>
                 </a:solidFill>
@@ -9335,7 +9279,7 @@
               </a:spcAft>
             </a:pPr>
             <a:r>
-              <a:rPr sz="1150" b="0">
+              <a:rPr sz="1150" b="0" dirty="0">
                 <a:solidFill>
                   <a:srgbClr val="262A2E"/>
                 </a:solidFill>
@@ -9354,7 +9298,7 @@
               </a:spcAft>
             </a:pPr>
             <a:r>
-              <a:rPr sz="1150" b="0">
+              <a:rPr sz="1150" b="0" dirty="0">
                 <a:solidFill>
                   <a:srgbClr val="262A2E"/>
                 </a:solidFill>
@@ -9373,7 +9317,7 @@
               </a:spcAft>
             </a:pPr>
             <a:r>
-              <a:rPr sz="1150" b="0">
+              <a:rPr sz="1150" b="0" dirty="0">
                 <a:solidFill>
                   <a:srgbClr val="262A2E"/>
                 </a:solidFill>
@@ -9392,7 +9336,7 @@
               </a:spcAft>
             </a:pPr>
             <a:r>
-              <a:rPr sz="1150" b="0">
+              <a:rPr sz="1150" b="0" dirty="0">
                 <a:solidFill>
                   <a:srgbClr val="262A2E"/>
                 </a:solidFill>
@@ -9411,7 +9355,7 @@
               </a:spcAft>
             </a:pPr>
             <a:r>
-              <a:rPr sz="1150" b="0">
+              <a:rPr sz="1150" b="0" dirty="0">
                 <a:solidFill>
                   <a:srgbClr val="262A2E"/>
                 </a:solidFill>
@@ -9430,7 +9374,7 @@
               </a:spcAft>
             </a:pPr>
             <a:r>
-              <a:rPr sz="1150" b="0">
+              <a:rPr sz="1150" b="0" dirty="0">
                 <a:solidFill>
                   <a:srgbClr val="262A2E"/>
                 </a:solidFill>
@@ -9449,7 +9393,7 @@
               </a:spcAft>
             </a:pPr>
             <a:r>
-              <a:rPr sz="1150" b="0">
+              <a:rPr sz="1150" b="0" dirty="0">
                 <a:solidFill>
                   <a:srgbClr val="262A2E"/>
                 </a:solidFill>
@@ -9468,7 +9412,7 @@
               </a:spcAft>
             </a:pPr>
             <a:r>
-              <a:rPr sz="1150" b="0">
+              <a:rPr sz="1150" b="0" dirty="0">
                 <a:solidFill>
                   <a:srgbClr val="262A2E"/>
                 </a:solidFill>
@@ -9487,7 +9431,7 @@
               </a:spcAft>
             </a:pPr>
             <a:r>
-              <a:rPr sz="1150" b="0">
+              <a:rPr sz="1150" b="0" dirty="0">
                 <a:solidFill>
                   <a:srgbClr val="262A2E"/>
                 </a:solidFill>
@@ -9506,13 +9450,31 @@
               </a:spcAft>
             </a:pPr>
             <a:r>
-              <a:rPr sz="1150" b="0">
+              <a:rPr sz="1150" b="0" dirty="0">
                 <a:solidFill>
                   <a:srgbClr val="262A2E"/>
                 </a:solidFill>
                 <a:latin typeface="Google Sans Flex Medium"/>
               </a:rPr>
-              <a:t>•  Agent interoperability: an MCP server (/mcp) and an A2A agent (/a2a) over the same engine.</a:t>
+              <a:t>•  Agent interoperability: an MCP server (/</a:t>
+            </a:r>
+            <a:r>
+              <a:rPr sz="1150" b="0" dirty="0" err="1">
+                <a:solidFill>
+                  <a:srgbClr val="262A2E"/>
+                </a:solidFill>
+                <a:latin typeface="Google Sans Flex Medium"/>
+              </a:rPr>
+              <a:t>mcp</a:t>
+            </a:r>
+            <a:r>
+              <a:rPr sz="1150" b="0" dirty="0">
+                <a:solidFill>
+                  <a:srgbClr val="262A2E"/>
+                </a:solidFill>
+                <a:latin typeface="Google Sans Flex Medium"/>
+              </a:rPr>
+              <a:t>) and an A2A agent (/a2a) over the same engine.</a:t>
             </a:r>
           </a:p>
           <a:p>
@@ -9525,7 +9487,7 @@
               </a:spcAft>
             </a:pPr>
             <a:r>
-              <a:rPr sz="1150" b="0">
+              <a:rPr sz="1150" b="0" dirty="0">
                 <a:solidFill>
                   <a:srgbClr val="262A2E"/>
                 </a:solidFill>
@@ -9691,15 +9653,15 @@
               <a:buNone/>
             </a:pPr>
             <a:r>
-              <a:rPr lang="en-GB" sz="1600">
+              <a:rPr lang="en-GB" sz="1600" dirty="0">
                 <a:latin typeface="Google Sans Flex Medium"/>
                 <a:ea typeface="Google Sans Flex Medium"/>
                 <a:cs typeface="Google Sans Flex Medium"/>
                 <a:sym typeface="Google Sans Flex Medium"/>
               </a:rPr>
-              <a:t>Process flow diagram or Use-case diagram</a:t>
-            </a:r>
-            <a:endParaRPr sz="1600">
+              <a:t>Process flow diagram</a:t>
+            </a:r>
+            <a:endParaRPr sz="1600" dirty="0">
               <a:latin typeface="Google Sans Flex Medium"/>
               <a:ea typeface="Google Sans Flex Medium"/>
               <a:cs typeface="Google Sans Flex Medium"/>
@@ -11481,7 +11443,7 @@
               <a:buNone/>
             </a:pPr>
             <a:r>
-              <a:rPr lang="en-GB" sz="1600">
+              <a:rPr lang="en-GB" sz="1600" dirty="0">
                 <a:latin typeface="Google Sans Flex Medium"/>
                 <a:ea typeface="Google Sans Flex Medium"/>
                 <a:cs typeface="Google Sans Flex Medium"/>
@@ -11489,7 +11451,7 @@
               </a:rPr>
               <a:t>Architecture diagram of the proposed solution</a:t>
             </a:r>
-            <a:endParaRPr sz="1600">
+            <a:endParaRPr sz="1600" dirty="0">
               <a:latin typeface="Google Sans Flex Medium"/>
               <a:ea typeface="Google Sans Flex Medium"/>
               <a:cs typeface="Google Sans Flex Medium"/>
@@ -13173,15 +13135,15 @@
               <a:buNone/>
             </a:pPr>
             <a:r>
-              <a:rPr lang="en-GB" sz="1600">
+              <a:rPr lang="en-GB" sz="1600" dirty="0">
                 <a:latin typeface="Google Sans Flex Medium"/>
                 <a:ea typeface="Google Sans Flex Medium"/>
                 <a:cs typeface="Google Sans Flex Medium"/>
                 <a:sym typeface="Google Sans Flex Medium"/>
               </a:rPr>
-              <a:t>Technologies to be used in the solution</a:t>
-            </a:r>
-            <a:endParaRPr sz="1600">
+              <a:t>Technologies used in the solution</a:t>
+            </a:r>
+            <a:endParaRPr sz="1600" dirty="0">
               <a:latin typeface="Google Sans Flex Medium"/>
               <a:ea typeface="Google Sans Flex Medium"/>
               <a:cs typeface="Google Sans Flex Medium"/>
@@ -13539,15 +13501,15 @@
               <a:buNone/>
             </a:pPr>
             <a:r>
-              <a:rPr lang="en-GB" sz="1600">
+              <a:rPr lang="en-GB" sz="1600" dirty="0">
                 <a:latin typeface="Google Sans Flex Medium"/>
                 <a:ea typeface="Google Sans Flex Medium"/>
                 <a:cs typeface="Google Sans Flex Medium"/>
                 <a:sym typeface="Google Sans Flex Medium"/>
               </a:rPr>
-              <a:t>Estimated implementation cost (optional)</a:t>
-            </a:r>
-            <a:endParaRPr sz="1600">
+              <a:t>Estimated implementation cost</a:t>
+            </a:r>
+            <a:endParaRPr sz="1600" dirty="0">
               <a:latin typeface="Google Sans Flex Medium"/>
               <a:ea typeface="Google Sans Flex Medium"/>
               <a:cs typeface="Google Sans Flex Medium"/>

</xml_diff>